<commit_message>
Update industry section PPT template
</commit_message>
<xml_diff>
--- a/assets/industry_section_template_master.pptx
+++ b/assets/industry_section_template_master.pptx
@@ -117,6 +117,11 @@
       </a:defRPr>
     </a:lvl9pPr>
   </p:defaultTextStyle>
+  <p:extLst>
+    <p:ext uri="{EFAFB233-063F-42B5-8137-9DF3F51BA10A}">
+      <p15:sldGuideLst xmlns:p15="http://schemas.microsoft.com/office/powerpoint/2012/main"/>
+    </p:ext>
+  </p:extLst>
 </p:presentation>
 </file>
 
@@ -202,7 +207,7 @@
           <a:p>
             <a:fld id="{4D58F495-25D7-974E-8942-5300ADB0351F}" type="datetimeFigureOut">
               <a:rPr kumimoji="1" lang="zh-CN" altLang="en-US" smtClean="0"/>
-              <a:t>2026/5/21</a:t>
+              <a:t>2026/5/25</a:t>
             </a:fld>
             <a:endParaRPr kumimoji="1" lang="zh-CN" altLang="en-US"/>
           </a:p>
@@ -700,7 +705,7 @@
           <a:p>
             <a:fld id="{4D43F9BF-FE5F-E647-B8EF-D6CA817AF965}" type="datetimeFigureOut">
               <a:rPr kumimoji="1" lang="zh-CN" altLang="en-US" smtClean="0"/>
-              <a:t>2026/5/21</a:t>
+              <a:t>2026/5/25</a:t>
             </a:fld>
             <a:endParaRPr kumimoji="1" lang="zh-CN" altLang="en-US"/>
           </a:p>
@@ -898,7 +903,7 @@
           <a:p>
             <a:fld id="{4D43F9BF-FE5F-E647-B8EF-D6CA817AF965}" type="datetimeFigureOut">
               <a:rPr kumimoji="1" lang="zh-CN" altLang="en-US" smtClean="0"/>
-              <a:t>2026/5/21</a:t>
+              <a:t>2026/5/25</a:t>
             </a:fld>
             <a:endParaRPr kumimoji="1" lang="zh-CN" altLang="en-US"/>
           </a:p>
@@ -1106,7 +1111,7 @@
           <a:p>
             <a:fld id="{4D43F9BF-FE5F-E647-B8EF-D6CA817AF965}" type="datetimeFigureOut">
               <a:rPr kumimoji="1" lang="zh-CN" altLang="en-US" smtClean="0"/>
-              <a:t>2026/5/21</a:t>
+              <a:t>2026/5/25</a:t>
             </a:fld>
             <a:endParaRPr kumimoji="1" lang="zh-CN" altLang="en-US"/>
           </a:p>
@@ -1329,7 +1334,7 @@
           <a:p>
             <a:fld id="{552EB9AE-4FB1-4E47-90BA-EAF6D948FEC5}" type="datetime1">
               <a:rPr lang="zh-CN" altLang="en-US" smtClean="0"/>
-              <a:t>2026/5/21</a:t>
+              <a:t>2026/5/25</a:t>
             </a:fld>
             <a:endParaRPr lang="zh-CN" altLang="en-US" dirty="0"/>
           </a:p>
@@ -1700,7 +1705,7 @@
           <a:p>
             <a:fld id="{4D43F9BF-FE5F-E647-B8EF-D6CA817AF965}" type="datetimeFigureOut">
               <a:rPr kumimoji="1" lang="zh-CN" altLang="en-US" smtClean="0"/>
-              <a:t>2026/5/21</a:t>
+              <a:t>2026/5/25</a:t>
             </a:fld>
             <a:endParaRPr kumimoji="1" lang="zh-CN" altLang="en-US"/>
           </a:p>
@@ -1975,7 +1980,7 @@
           <a:p>
             <a:fld id="{4D43F9BF-FE5F-E647-B8EF-D6CA817AF965}" type="datetimeFigureOut">
               <a:rPr kumimoji="1" lang="zh-CN" altLang="en-US" smtClean="0"/>
-              <a:t>2026/5/21</a:t>
+              <a:t>2026/5/25</a:t>
             </a:fld>
             <a:endParaRPr kumimoji="1" lang="zh-CN" altLang="en-US"/>
           </a:p>
@@ -2240,7 +2245,7 @@
           <a:p>
             <a:fld id="{4D43F9BF-FE5F-E647-B8EF-D6CA817AF965}" type="datetimeFigureOut">
               <a:rPr kumimoji="1" lang="zh-CN" altLang="en-US" smtClean="0"/>
-              <a:t>2026/5/21</a:t>
+              <a:t>2026/5/25</a:t>
             </a:fld>
             <a:endParaRPr kumimoji="1" lang="zh-CN" altLang="en-US"/>
           </a:p>
@@ -2652,7 +2657,7 @@
           <a:p>
             <a:fld id="{4D43F9BF-FE5F-E647-B8EF-D6CA817AF965}" type="datetimeFigureOut">
               <a:rPr kumimoji="1" lang="zh-CN" altLang="en-US" smtClean="0"/>
-              <a:t>2026/5/21</a:t>
+              <a:t>2026/5/25</a:t>
             </a:fld>
             <a:endParaRPr kumimoji="1" lang="zh-CN" altLang="en-US"/>
           </a:p>
@@ -2793,7 +2798,7 @@
           <a:p>
             <a:fld id="{4D43F9BF-FE5F-E647-B8EF-D6CA817AF965}" type="datetimeFigureOut">
               <a:rPr kumimoji="1" lang="zh-CN" altLang="en-US" smtClean="0"/>
-              <a:t>2026/5/21</a:t>
+              <a:t>2026/5/25</a:t>
             </a:fld>
             <a:endParaRPr kumimoji="1" lang="zh-CN" altLang="en-US"/>
           </a:p>
@@ -2906,7 +2911,7 @@
           <a:p>
             <a:fld id="{4D43F9BF-FE5F-E647-B8EF-D6CA817AF965}" type="datetimeFigureOut">
               <a:rPr kumimoji="1" lang="zh-CN" altLang="en-US" smtClean="0"/>
-              <a:t>2026/5/21</a:t>
+              <a:t>2026/5/25</a:t>
             </a:fld>
             <a:endParaRPr kumimoji="1" lang="zh-CN" altLang="en-US"/>
           </a:p>
@@ -3217,7 +3222,7 @@
           <a:p>
             <a:fld id="{4D43F9BF-FE5F-E647-B8EF-D6CA817AF965}" type="datetimeFigureOut">
               <a:rPr kumimoji="1" lang="zh-CN" altLang="en-US" smtClean="0"/>
-              <a:t>2026/5/21</a:t>
+              <a:t>2026/5/25</a:t>
             </a:fld>
             <a:endParaRPr kumimoji="1" lang="zh-CN" altLang="en-US"/>
           </a:p>
@@ -3505,7 +3510,7 @@
           <a:p>
             <a:fld id="{4D43F9BF-FE5F-E647-B8EF-D6CA817AF965}" type="datetimeFigureOut">
               <a:rPr kumimoji="1" lang="zh-CN" altLang="en-US" smtClean="0"/>
-              <a:t>2026/5/21</a:t>
+              <a:t>2026/5/25</a:t>
             </a:fld>
             <a:endParaRPr kumimoji="1" lang="zh-CN" altLang="en-US"/>
           </a:p>
@@ -3746,7 +3751,7 @@
           <a:p>
             <a:fld id="{4D43F9BF-FE5F-E647-B8EF-D6CA817AF965}" type="datetimeFigureOut">
               <a:rPr kumimoji="1" lang="zh-CN" altLang="en-US" smtClean="0"/>
-              <a:t>2026/5/21</a:t>
+              <a:t>2026/5/25</a:t>
             </a:fld>
             <a:endParaRPr kumimoji="1" lang="zh-CN" altLang="en-US"/>
           </a:p>
@@ -4304,7 +4309,7 @@
           <a:ln/>
         </p:spPr>
         <p:txBody>
-          <a:bodyPr wrap="square" lIns="0" tIns="0" rIns="0" bIns="0" rtlCol="0" anchor="ctr"/>
+          <a:bodyPr wrap="square" lIns="0" tIns="0" rIns="0" bIns="0" rtlCol="0" anchor="t"/>
           <a:lstStyle/>
           <a:p>
             <a:pPr marL="90488">
@@ -5100,7 +5105,7 @@
           <a:ln/>
         </p:spPr>
         <p:txBody>
-          <a:bodyPr wrap="square" lIns="0" tIns="0" rIns="0" bIns="0" rtlCol="0" anchor="ctr"/>
+          <a:bodyPr wrap="square" lIns="0" tIns="0" rIns="0" bIns="0" rtlCol="0" anchor="t"/>
           <a:lstStyle/>
           <a:p>
             <a:pPr marL="90488">
@@ -6137,7 +6142,7 @@
           <a:ln/>
         </p:spPr>
         <p:txBody>
-          <a:bodyPr wrap="square" lIns="0" tIns="0" rIns="0" bIns="0" rtlCol="0" anchor="ctr"/>
+          <a:bodyPr wrap="square" lIns="0" tIns="0" rIns="0" bIns="0" rtlCol="0" anchor="t"/>
           <a:lstStyle/>
           <a:p>
             <a:pPr marL="90488">
@@ -7234,7 +7239,7 @@
           <a:ln/>
         </p:spPr>
         <p:txBody>
-          <a:bodyPr wrap="square" lIns="0" tIns="0" rIns="0" bIns="0" rtlCol="0" anchor="ctr"/>
+          <a:bodyPr wrap="square" lIns="0" tIns="0" rIns="0" bIns="0" rtlCol="0" anchor="t"/>
           <a:lstStyle/>
           <a:p>
             <a:pPr marL="90488">
@@ -8499,7 +8504,7 @@
           <a:ln/>
         </p:spPr>
         <p:txBody>
-          <a:bodyPr wrap="square" lIns="0" tIns="0" rIns="0" bIns="0" rtlCol="0" anchor="ctr"/>
+          <a:bodyPr wrap="square" lIns="0" tIns="0" rIns="0" bIns="0" rtlCol="0" anchor="t"/>
           <a:lstStyle/>
           <a:p>
             <a:pPr marL="90488">
@@ -9416,6 +9421,8 @@
                 <a:solidFill>
                   <a:srgbClr val="64748B"/>
                 </a:solidFill>
+                <a:latin typeface="Microsoft YaHei" panose="020B0503020204020204" pitchFamily="34" charset="-122"/>
+                <a:ea typeface="Microsoft YaHei" panose="020B0503020204020204" pitchFamily="34" charset="-122"/>
               </a:rPr>
               <a:t>{{slide_02b_table_header_1}}</a:t>
             </a:r>
@@ -9457,10 +9464,15 @@
                 <a:solidFill>
                   <a:srgbClr val="64748B"/>
                 </a:solidFill>
+                <a:latin typeface="Microsoft YaHei" panose="020B0503020204020204" pitchFamily="34" charset="-122"/>
+                <a:ea typeface="Microsoft YaHei" panose="020B0503020204020204" pitchFamily="34" charset="-122"/>
               </a:rPr>
               <a:t>{{slide_02b_table_header_2}}</a:t>
             </a:r>
-            <a:endParaRPr lang="en-US" sz="1000" dirty="0"/>
+            <a:endParaRPr lang="en-US" sz="1000" dirty="0">
+              <a:latin typeface="Microsoft YaHei" panose="020B0503020204020204" pitchFamily="34" charset="-122"/>
+              <a:ea typeface="Microsoft YaHei" panose="020B0503020204020204" pitchFamily="34" charset="-122"/>
+            </a:endParaRPr>
           </a:p>
         </p:txBody>
       </p:sp>
@@ -9499,10 +9511,15 @@
                 <a:solidFill>
                   <a:srgbClr val="1E293B"/>
                 </a:solidFill>
+                <a:latin typeface="Microsoft YaHei" panose="020B0503020204020204" pitchFamily="34" charset="-122"/>
+                <a:ea typeface="Microsoft YaHei" panose="020B0503020204020204" pitchFamily="34" charset="-122"/>
               </a:rPr>
               <a:t>{{slide_02b_table_row_1}}</a:t>
             </a:r>
-            <a:endParaRPr lang="en-US" sz="1000" dirty="0"/>
+            <a:endParaRPr lang="en-US" sz="1000" dirty="0">
+              <a:latin typeface="Microsoft YaHei" panose="020B0503020204020204" pitchFamily="34" charset="-122"/>
+              <a:ea typeface="Microsoft YaHei" panose="020B0503020204020204" pitchFamily="34" charset="-122"/>
+            </a:endParaRPr>
           </a:p>
         </p:txBody>
       </p:sp>
@@ -9541,10 +9558,15 @@
                 <a:solidFill>
                   <a:srgbClr val="1E293B"/>
                 </a:solidFill>
+                <a:latin typeface="Microsoft YaHei" panose="020B0503020204020204" pitchFamily="34" charset="-122"/>
+                <a:ea typeface="Microsoft YaHei" panose="020B0503020204020204" pitchFamily="34" charset="-122"/>
               </a:rPr>
               <a:t>{{slide_02b_table_row_2}}</a:t>
             </a:r>
-            <a:endParaRPr lang="en-US" sz="1000" dirty="0"/>
+            <a:endParaRPr lang="en-US" sz="1000" dirty="0">
+              <a:latin typeface="Microsoft YaHei" panose="020B0503020204020204" pitchFamily="34" charset="-122"/>
+              <a:ea typeface="Microsoft YaHei" panose="020B0503020204020204" pitchFamily="34" charset="-122"/>
+            </a:endParaRPr>
           </a:p>
         </p:txBody>
       </p:sp>
@@ -9583,10 +9605,15 @@
                 <a:solidFill>
                   <a:srgbClr val="1E293B"/>
                 </a:solidFill>
+                <a:latin typeface="Microsoft YaHei" panose="020B0503020204020204" pitchFamily="34" charset="-122"/>
+                <a:ea typeface="Microsoft YaHei" panose="020B0503020204020204" pitchFamily="34" charset="-122"/>
               </a:rPr>
               <a:t>{{slide_02b_table_row_3}}</a:t>
             </a:r>
-            <a:endParaRPr lang="en-US" sz="1000" dirty="0"/>
+            <a:endParaRPr lang="en-US" sz="1000" dirty="0">
+              <a:latin typeface="Microsoft YaHei" panose="020B0503020204020204" pitchFamily="34" charset="-122"/>
+              <a:ea typeface="Microsoft YaHei" panose="020B0503020204020204" pitchFamily="34" charset="-122"/>
+            </a:endParaRPr>
           </a:p>
         </p:txBody>
       </p:sp>
@@ -9916,7 +9943,7 @@
           <a:ln/>
         </p:spPr>
         <p:txBody>
-          <a:bodyPr wrap="square" lIns="0" tIns="0" rIns="0" bIns="0" rtlCol="0" anchor="ctr"/>
+          <a:bodyPr wrap="square" lIns="0" tIns="0" rIns="0" bIns="0" rtlCol="0" anchor="t"/>
           <a:lstStyle/>
           <a:p>
             <a:pPr marL="90488">
@@ -11005,7 +11032,7 @@
           <a:ln/>
         </p:spPr>
         <p:txBody>
-          <a:bodyPr wrap="square" lIns="0" tIns="0" rIns="0" bIns="0" rtlCol="0" anchor="ctr"/>
+          <a:bodyPr wrap="square" lIns="0" tIns="0" rIns="0" bIns="0" rtlCol="0" anchor="t"/>
           <a:lstStyle/>
           <a:p>
             <a:pPr marL="90488">
@@ -12410,7 +12437,7 @@
           <a:ln/>
         </p:spPr>
         <p:txBody>
-          <a:bodyPr wrap="square" lIns="0" tIns="0" rIns="0" bIns="0" rtlCol="0" anchor="ctr"/>
+          <a:bodyPr wrap="square" lIns="0" tIns="0" rIns="0" bIns="0" rtlCol="0" anchor="t"/>
           <a:lstStyle/>
           <a:p>
             <a:pPr marL="90488">
@@ -13343,7 +13370,7 @@
           <a:ln/>
         </p:spPr>
         <p:txBody>
-          <a:bodyPr wrap="square" lIns="0" tIns="0" rIns="0" bIns="0" rtlCol="0" anchor="ctr"/>
+          <a:bodyPr wrap="square" lIns="0" tIns="0" rIns="0" bIns="0" rtlCol="0" anchor="t"/>
           <a:lstStyle/>
           <a:p>
             <a:pPr marL="90488">
@@ -13545,7 +13572,7 @@
                   <a:srgbClr val="777777"/>
                 </a:solidFill>
                 <a:latin typeface="Arial" pitchFamily="34" charset="0"/>
-                <a:ea typeface="Arial" pitchFamily="34" charset="-122"/>
+                <a:ea typeface="Microsoft YaHei" panose="020B0503020204020204" pitchFamily="34" charset="-122"/>
                 <a:cs typeface="Arial" pitchFamily="34" charset="-120"/>
               </a:rPr>
               <a:t>PEER COMPARE TABLE</a:t>
@@ -14661,10 +14688,15 @@
                 <a:solidFill>
                   <a:srgbClr val="64748B"/>
                 </a:solidFill>
+                <a:latin typeface="Microsoft YaHei" panose="020B0503020204020204" pitchFamily="34" charset="-122"/>
+                <a:ea typeface="Microsoft YaHei" panose="020B0503020204020204" pitchFamily="34" charset="-122"/>
               </a:rPr>
               <a:t>{{slide_06a_table_header}}</a:t>
             </a:r>
-            <a:endParaRPr lang="en-US" sz="1000" dirty="0"/>
+            <a:endParaRPr lang="en-US" sz="1000" dirty="0">
+              <a:latin typeface="Microsoft YaHei" panose="020B0503020204020204" pitchFamily="34" charset="-122"/>
+              <a:ea typeface="Microsoft YaHei" panose="020B0503020204020204" pitchFamily="34" charset="-122"/>
+            </a:endParaRPr>
           </a:p>
         </p:txBody>
       </p:sp>
@@ -14703,10 +14735,15 @@
                 <a:solidFill>
                   <a:srgbClr val="1E293B"/>
                 </a:solidFill>
+                <a:latin typeface="Microsoft YaHei" panose="020B0503020204020204" pitchFamily="34" charset="-122"/>
+                <a:ea typeface="Microsoft YaHei" panose="020B0503020204020204" pitchFamily="34" charset="-122"/>
               </a:rPr>
               <a:t>{{slide_06a_table_row_1}}</a:t>
             </a:r>
-            <a:endParaRPr lang="en-US" sz="1000" dirty="0"/>
+            <a:endParaRPr lang="en-US" sz="1000" dirty="0">
+              <a:latin typeface="Microsoft YaHei" panose="020B0503020204020204" pitchFamily="34" charset="-122"/>
+              <a:ea typeface="Microsoft YaHei" panose="020B0503020204020204" pitchFamily="34" charset="-122"/>
+            </a:endParaRPr>
           </a:p>
         </p:txBody>
       </p:sp>
@@ -14745,10 +14782,15 @@
                 <a:solidFill>
                   <a:srgbClr val="1E293B"/>
                 </a:solidFill>
+                <a:latin typeface="Microsoft YaHei" panose="020B0503020204020204" pitchFamily="34" charset="-122"/>
+                <a:ea typeface="Microsoft YaHei" panose="020B0503020204020204" pitchFamily="34" charset="-122"/>
               </a:rPr>
               <a:t>{{slide_06a_table_row_2}}</a:t>
             </a:r>
-            <a:endParaRPr lang="en-US" sz="1000" dirty="0"/>
+            <a:endParaRPr lang="en-US" sz="1000" dirty="0">
+              <a:latin typeface="Microsoft YaHei" panose="020B0503020204020204" pitchFamily="34" charset="-122"/>
+              <a:ea typeface="Microsoft YaHei" panose="020B0503020204020204" pitchFamily="34" charset="-122"/>
+            </a:endParaRPr>
           </a:p>
         </p:txBody>
       </p:sp>
@@ -14787,10 +14829,15 @@
                 <a:solidFill>
                   <a:srgbClr val="1E293B"/>
                 </a:solidFill>
+                <a:latin typeface="Microsoft YaHei" panose="020B0503020204020204" pitchFamily="34" charset="-122"/>
+                <a:ea typeface="Microsoft YaHei" panose="020B0503020204020204" pitchFamily="34" charset="-122"/>
               </a:rPr>
               <a:t>{{slide_06a_table_row_3}}</a:t>
             </a:r>
-            <a:endParaRPr lang="en-US" sz="1000" dirty="0"/>
+            <a:endParaRPr lang="en-US" sz="1000" dirty="0">
+              <a:latin typeface="Microsoft YaHei" panose="020B0503020204020204" pitchFamily="34" charset="-122"/>
+              <a:ea typeface="Microsoft YaHei" panose="020B0503020204020204" pitchFamily="34" charset="-122"/>
+            </a:endParaRPr>
           </a:p>
         </p:txBody>
       </p:sp>
@@ -14829,10 +14876,15 @@
                 <a:solidFill>
                   <a:srgbClr val="1E293B"/>
                 </a:solidFill>
+                <a:latin typeface="Microsoft YaHei" panose="020B0503020204020204" pitchFamily="34" charset="-122"/>
+                <a:ea typeface="Microsoft YaHei" panose="020B0503020204020204" pitchFamily="34" charset="-122"/>
               </a:rPr>
               <a:t>{{slide_06a_table_row_4}}</a:t>
             </a:r>
-            <a:endParaRPr lang="en-US" sz="1000" dirty="0"/>
+            <a:endParaRPr lang="en-US" sz="1000" dirty="0">
+              <a:latin typeface="Microsoft YaHei" panose="020B0503020204020204" pitchFamily="34" charset="-122"/>
+              <a:ea typeface="Microsoft YaHei" panose="020B0503020204020204" pitchFamily="34" charset="-122"/>
+            </a:endParaRPr>
           </a:p>
         </p:txBody>
       </p:sp>
@@ -14871,10 +14923,15 @@
                 <a:solidFill>
                   <a:srgbClr val="1E293B"/>
                 </a:solidFill>
+                <a:latin typeface="Microsoft YaHei" panose="020B0503020204020204" pitchFamily="34" charset="-122"/>
+                <a:ea typeface="Microsoft YaHei" panose="020B0503020204020204" pitchFamily="34" charset="-122"/>
               </a:rPr>
               <a:t>{{slide_06a_table_row_5}}</a:t>
             </a:r>
-            <a:endParaRPr lang="en-US" sz="1000" dirty="0"/>
+            <a:endParaRPr lang="en-US" sz="1000" dirty="0">
+              <a:latin typeface="Microsoft YaHei" panose="020B0503020204020204" pitchFamily="34" charset="-122"/>
+              <a:ea typeface="Microsoft YaHei" panose="020B0503020204020204" pitchFamily="34" charset="-122"/>
+            </a:endParaRPr>
           </a:p>
         </p:txBody>
       </p:sp>
@@ -14913,10 +14970,15 @@
                 <a:solidFill>
                   <a:srgbClr val="1E293B"/>
                 </a:solidFill>
+                <a:latin typeface="Microsoft YaHei" panose="020B0503020204020204" pitchFamily="34" charset="-122"/>
+                <a:ea typeface="Microsoft YaHei" panose="020B0503020204020204" pitchFamily="34" charset="-122"/>
               </a:rPr>
               <a:t>{{slide_06a_table_row_6}}</a:t>
             </a:r>
-            <a:endParaRPr lang="en-US" sz="1000" dirty="0"/>
+            <a:endParaRPr lang="en-US" sz="1000" dirty="0">
+              <a:latin typeface="Microsoft YaHei" panose="020B0503020204020204" pitchFamily="34" charset="-122"/>
+              <a:ea typeface="Microsoft YaHei" panose="020B0503020204020204" pitchFamily="34" charset="-122"/>
+            </a:endParaRPr>
           </a:p>
         </p:txBody>
       </p:sp>
@@ -15162,7 +15224,7 @@
           <a:ln/>
         </p:spPr>
         <p:txBody>
-          <a:bodyPr wrap="square" lIns="0" tIns="0" rIns="0" bIns="0" rtlCol="0" anchor="ctr"/>
+          <a:bodyPr wrap="square" lIns="0" tIns="0" rIns="0" bIns="0" rtlCol="0" anchor="t"/>
           <a:lstStyle/>
           <a:p>
             <a:pPr marL="90488">
@@ -16486,7 +16548,7 @@
           <a:ln/>
         </p:spPr>
         <p:txBody>
-          <a:bodyPr wrap="square" lIns="0" tIns="0" rIns="0" bIns="0" rtlCol="0" anchor="ctr"/>
+          <a:bodyPr wrap="square" lIns="0" tIns="0" rIns="0" bIns="0" rtlCol="0" anchor="t"/>
           <a:lstStyle/>
           <a:p>
             <a:pPr marL="90488">

</xml_diff>

<commit_message>
Improve PPT visual fit and chart rendering
</commit_message>
<xml_diff>
--- a/assets/industry_section_template_master.pptx
+++ b/assets/industry_section_template_master.pptx
@@ -4559,6 +4559,9 @@
           <a:lstStyle/>
           <a:p>
             <a:pPr marL="0" indent="0">
+              <a:lnSpc>
+                <a:spcPct val="110000"/>
+              </a:lnSpc>
               <a:buNone/>
             </a:pPr>
             <a:r>
@@ -4576,12 +4579,18 @@
           </a:p>
           <a:p>
             <a:pPr marL="0" indent="0">
+              <a:lnSpc>
+                <a:spcPct val="110000"/>
+              </a:lnSpc>
               <a:buNone/>
             </a:pPr>
             <a:endParaRPr lang="en-US" sz="1000" dirty="0"/>
           </a:p>
           <a:p>
             <a:pPr marL="0" indent="0">
+              <a:lnSpc>
+                <a:spcPct val="110000"/>
+              </a:lnSpc>
               <a:buNone/>
             </a:pPr>
             <a:r>
@@ -4599,12 +4608,18 @@
           </a:p>
           <a:p>
             <a:pPr marL="0" indent="0">
+              <a:lnSpc>
+                <a:spcPct val="110000"/>
+              </a:lnSpc>
               <a:buNone/>
             </a:pPr>
             <a:endParaRPr lang="en-US" sz="1000" dirty="0"/>
           </a:p>
           <a:p>
             <a:pPr marL="0" indent="0">
+              <a:lnSpc>
+                <a:spcPct val="110000"/>
+              </a:lnSpc>
               <a:buNone/>
             </a:pPr>
             <a:r>
@@ -5592,6 +5607,9 @@
           <a:lstStyle/>
           <a:p>
             <a:pPr marL="0" indent="0">
+              <a:lnSpc>
+                <a:spcPct val="110000"/>
+              </a:lnSpc>
               <a:buNone/>
             </a:pPr>
             <a:r>
@@ -5670,6 +5688,9 @@
           <a:lstStyle/>
           <a:p>
             <a:pPr marL="0" indent="0">
+              <a:lnSpc>
+                <a:spcPct val="110000"/>
+              </a:lnSpc>
               <a:buNone/>
             </a:pPr>
             <a:r>
@@ -5748,6 +5769,9 @@
           <a:lstStyle/>
           <a:p>
             <a:pPr marL="0" indent="0">
+              <a:lnSpc>
+                <a:spcPct val="110000"/>
+              </a:lnSpc>
               <a:buNone/>
             </a:pPr>
             <a:r>
@@ -5826,6 +5850,9 @@
           <a:lstStyle/>
           <a:p>
             <a:pPr marL="0" indent="0">
+              <a:lnSpc>
+                <a:spcPct val="110000"/>
+              </a:lnSpc>
               <a:buNone/>
             </a:pPr>
             <a:r>
@@ -6414,6 +6441,9 @@
           <a:lstStyle/>
           <a:p>
             <a:pPr marL="0" indent="0">
+              <a:lnSpc>
+                <a:spcPct val="110000"/>
+              </a:lnSpc>
               <a:buNone/>
             </a:pPr>
             <a:r>
@@ -6574,6 +6604,9 @@
           <a:lstStyle/>
           <a:p>
             <a:pPr marL="0" indent="0">
+              <a:lnSpc>
+                <a:spcPct val="110000"/>
+              </a:lnSpc>
               <a:buNone/>
             </a:pPr>
             <a:r>
@@ -6730,6 +6763,9 @@
           <a:lstStyle/>
           <a:p>
             <a:pPr marL="0" indent="0">
+              <a:lnSpc>
+                <a:spcPct val="110000"/>
+              </a:lnSpc>
               <a:buNone/>
             </a:pPr>
             <a:r>
@@ -6890,6 +6926,9 @@
           <a:lstStyle/>
           <a:p>
             <a:pPr marL="0" indent="0">
+              <a:lnSpc>
+                <a:spcPct val="110000"/>
+              </a:lnSpc>
               <a:buNone/>
             </a:pPr>
             <a:r>
@@ -7695,6 +7734,9 @@
           <a:lstStyle/>
           <a:p>
             <a:pPr marL="0" indent="0">
+              <a:lnSpc>
+                <a:spcPct val="110000"/>
+              </a:lnSpc>
               <a:buNone/>
             </a:pPr>
             <a:r>
@@ -7865,6 +7907,9 @@
           <a:lstStyle/>
           <a:p>
             <a:pPr marL="0" indent="0">
+              <a:lnSpc>
+                <a:spcPct val="110000"/>
+              </a:lnSpc>
               <a:buNone/>
             </a:pPr>
             <a:r>
@@ -8035,6 +8080,9 @@
           <a:lstStyle/>
           <a:p>
             <a:pPr marL="0" indent="0">
+              <a:lnSpc>
+                <a:spcPct val="110000"/>
+              </a:lnSpc>
               <a:buNone/>
             </a:pPr>
             <a:r>
@@ -8128,7 +8176,12 @@
           <a:bodyPr/>
           <a:lstStyle/>
           <a:p>
-            <a:endParaRPr/>
+            <a:pPr>
+              <a:lnSpc>
+                <a:spcPct val="110000"/>
+              </a:lnSpc>
+            </a:pPr>
+            <a:endParaRPr dirty="0"/>
           </a:p>
         </p:txBody>
       </p:sp>
@@ -8960,6 +9013,9 @@
           <a:lstStyle/>
           <a:p>
             <a:pPr marL="0" indent="0">
+              <a:lnSpc>
+                <a:spcPct val="110000"/>
+              </a:lnSpc>
               <a:buNone/>
             </a:pPr>
             <a:r>
@@ -9130,6 +9186,9 @@
           <a:lstStyle/>
           <a:p>
             <a:pPr marL="0" indent="0">
+              <a:lnSpc>
+                <a:spcPct val="110000"/>
+              </a:lnSpc>
               <a:buNone/>
             </a:pPr>
             <a:r>
@@ -10215,6 +10274,9 @@
           <a:lstStyle/>
           <a:p>
             <a:pPr marL="0" indent="0">
+              <a:lnSpc>
+                <a:spcPct val="110000"/>
+              </a:lnSpc>
               <a:buNone/>
             </a:pPr>
             <a:r>
@@ -10371,6 +10433,9 @@
           <a:lstStyle/>
           <a:p>
             <a:pPr marL="0" indent="0">
+              <a:lnSpc>
+                <a:spcPct val="110000"/>
+              </a:lnSpc>
               <a:buNone/>
             </a:pPr>
             <a:r>
@@ -10527,6 +10592,9 @@
           <a:lstStyle/>
           <a:p>
             <a:pPr marL="0" indent="0">
+              <a:lnSpc>
+                <a:spcPct val="110000"/>
+              </a:lnSpc>
               <a:buNone/>
             </a:pPr>
             <a:r>
@@ -10683,6 +10751,9 @@
           <a:lstStyle/>
           <a:p>
             <a:pPr marL="0" indent="0">
+              <a:lnSpc>
+                <a:spcPct val="110000"/>
+              </a:lnSpc>
               <a:buNone/>
             </a:pPr>
             <a:r>
@@ -11304,6 +11375,9 @@
           <a:lstStyle/>
           <a:p>
             <a:pPr marL="0" indent="0">
+              <a:lnSpc>
+                <a:spcPct val="110000"/>
+              </a:lnSpc>
               <a:buNone/>
             </a:pPr>
             <a:r>
@@ -11460,6 +11534,9 @@
           <a:lstStyle/>
           <a:p>
             <a:pPr marL="0" indent="0">
+              <a:lnSpc>
+                <a:spcPct val="110000"/>
+              </a:lnSpc>
               <a:buNone/>
             </a:pPr>
             <a:r>
@@ -11616,6 +11693,9 @@
           <a:lstStyle/>
           <a:p>
             <a:pPr marL="0" indent="0">
+              <a:lnSpc>
+                <a:spcPct val="110000"/>
+              </a:lnSpc>
               <a:buNone/>
             </a:pPr>
             <a:r>
@@ -11772,6 +11852,9 @@
           <a:lstStyle/>
           <a:p>
             <a:pPr marL="0" indent="0">
+              <a:lnSpc>
+                <a:spcPct val="110000"/>
+              </a:lnSpc>
               <a:buNone/>
             </a:pPr>
             <a:r>
@@ -11928,6 +12011,9 @@
           <a:lstStyle/>
           <a:p>
             <a:pPr marL="0" indent="0">
+              <a:lnSpc>
+                <a:spcPct val="110000"/>
+              </a:lnSpc>
               <a:buNone/>
             </a:pPr>
             <a:r>
@@ -12088,6 +12174,9 @@
           <a:lstStyle/>
           <a:p>
             <a:pPr marL="0" indent="0">
+              <a:lnSpc>
+                <a:spcPct val="110000"/>
+              </a:lnSpc>
               <a:buNone/>
             </a:pPr>
             <a:r>
@@ -12709,6 +12798,9 @@
           <a:lstStyle/>
           <a:p>
             <a:pPr marL="0" indent="0">
+              <a:lnSpc>
+                <a:spcPct val="110000"/>
+              </a:lnSpc>
               <a:buNone/>
             </a:pPr>
             <a:r>
@@ -12865,6 +12957,9 @@
           <a:lstStyle/>
           <a:p>
             <a:pPr marL="0" indent="0">
+              <a:lnSpc>
+                <a:spcPct val="110000"/>
+              </a:lnSpc>
               <a:buNone/>
             </a:pPr>
             <a:r>
@@ -13021,6 +13116,9 @@
           <a:lstStyle/>
           <a:p>
             <a:pPr marL="0" indent="0">
+              <a:lnSpc>
+                <a:spcPct val="110000"/>
+              </a:lnSpc>
               <a:buNone/>
             </a:pPr>
             <a:r>
@@ -13762,6 +13860,9 @@
           <a:lstStyle/>
           <a:p>
             <a:pPr marL="0" indent="0">
+              <a:lnSpc>
+                <a:spcPct val="110000"/>
+              </a:lnSpc>
               <a:buNone/>
             </a:pPr>
             <a:r>
@@ -13918,6 +14019,9 @@
           <a:lstStyle/>
           <a:p>
             <a:pPr marL="0" indent="0">
+              <a:lnSpc>
+                <a:spcPct val="110000"/>
+              </a:lnSpc>
               <a:buNone/>
             </a:pPr>
             <a:r>
@@ -14078,6 +14182,9 @@
           <a:lstStyle/>
           <a:p>
             <a:pPr marL="0" indent="0">
+              <a:lnSpc>
+                <a:spcPct val="110000"/>
+              </a:lnSpc>
               <a:buNone/>
             </a:pPr>
             <a:r>
@@ -15624,6 +15731,9 @@
           <a:lstStyle/>
           <a:p>
             <a:pPr marL="0" indent="0">
+              <a:lnSpc>
+                <a:spcPct val="110000"/>
+              </a:lnSpc>
               <a:buNone/>
             </a:pPr>
             <a:r>
@@ -15780,6 +15890,9 @@
           <a:lstStyle/>
           <a:p>
             <a:pPr marL="0" indent="0">
+              <a:lnSpc>
+                <a:spcPct val="110000"/>
+              </a:lnSpc>
               <a:buNone/>
             </a:pPr>
             <a:r>
@@ -15940,6 +16053,9 @@
           <a:lstStyle/>
           <a:p>
             <a:pPr marL="0" indent="0">
+              <a:lnSpc>
+                <a:spcPct val="110000"/>
+              </a:lnSpc>
               <a:buNone/>
             </a:pPr>
             <a:r>
@@ -16819,6 +16935,9 @@
           <a:lstStyle/>
           <a:p>
             <a:pPr marL="0" indent="0">
+              <a:lnSpc>
+                <a:spcPct val="110000"/>
+              </a:lnSpc>
               <a:buNone/>
             </a:pPr>
             <a:r>
@@ -16971,6 +17090,9 @@
           <a:lstStyle/>
           <a:p>
             <a:pPr marL="0" indent="0">
+              <a:lnSpc>
+                <a:spcPct val="110000"/>
+              </a:lnSpc>
               <a:buNone/>
             </a:pPr>
             <a:r>
@@ -17124,6 +17246,9 @@
           <a:lstStyle/>
           <a:p>
             <a:pPr marL="0" indent="0">
+              <a:lnSpc>
+                <a:spcPct val="110000"/>
+              </a:lnSpc>
               <a:buNone/>
             </a:pPr>
             <a:r>

</xml_diff>

<commit_message>
Update PPTX master template
</commit_message>
<xml_diff>
--- a/assets/industry_section_template_master.pptx
+++ b/assets/industry_section_template_master.pptx
@@ -207,7 +207,7 @@
           <a:p>
             <a:fld id="{4D58F495-25D7-974E-8942-5300ADB0351F}" type="datetimeFigureOut">
               <a:rPr kumimoji="1" lang="zh-CN" altLang="en-US" smtClean="0"/>
-              <a:t>2026/5/25</a:t>
+              <a:t>2026/5/27</a:t>
             </a:fld>
             <a:endParaRPr kumimoji="1" lang="zh-CN" altLang="en-US"/>
           </a:p>
@@ -705,7 +705,7 @@
           <a:p>
             <a:fld id="{4D43F9BF-FE5F-E647-B8EF-D6CA817AF965}" type="datetimeFigureOut">
               <a:rPr kumimoji="1" lang="zh-CN" altLang="en-US" smtClean="0"/>
-              <a:t>2026/5/25</a:t>
+              <a:t>2026/5/27</a:t>
             </a:fld>
             <a:endParaRPr kumimoji="1" lang="zh-CN" altLang="en-US"/>
           </a:p>
@@ -903,7 +903,7 @@
           <a:p>
             <a:fld id="{4D43F9BF-FE5F-E647-B8EF-D6CA817AF965}" type="datetimeFigureOut">
               <a:rPr kumimoji="1" lang="zh-CN" altLang="en-US" smtClean="0"/>
-              <a:t>2026/5/25</a:t>
+              <a:t>2026/5/27</a:t>
             </a:fld>
             <a:endParaRPr kumimoji="1" lang="zh-CN" altLang="en-US"/>
           </a:p>
@@ -1111,7 +1111,7 @@
           <a:p>
             <a:fld id="{4D43F9BF-FE5F-E647-B8EF-D6CA817AF965}" type="datetimeFigureOut">
               <a:rPr kumimoji="1" lang="zh-CN" altLang="en-US" smtClean="0"/>
-              <a:t>2026/5/25</a:t>
+              <a:t>2026/5/27</a:t>
             </a:fld>
             <a:endParaRPr kumimoji="1" lang="zh-CN" altLang="en-US"/>
           </a:p>
@@ -1334,7 +1334,7 @@
           <a:p>
             <a:fld id="{552EB9AE-4FB1-4E47-90BA-EAF6D948FEC5}" type="datetime1">
               <a:rPr lang="zh-CN" altLang="en-US" smtClean="0"/>
-              <a:t>2026/5/25</a:t>
+              <a:t>2026/5/27</a:t>
             </a:fld>
             <a:endParaRPr lang="zh-CN" altLang="en-US" dirty="0"/>
           </a:p>
@@ -1705,7 +1705,7 @@
           <a:p>
             <a:fld id="{4D43F9BF-FE5F-E647-B8EF-D6CA817AF965}" type="datetimeFigureOut">
               <a:rPr kumimoji="1" lang="zh-CN" altLang="en-US" smtClean="0"/>
-              <a:t>2026/5/25</a:t>
+              <a:t>2026/5/27</a:t>
             </a:fld>
             <a:endParaRPr kumimoji="1" lang="zh-CN" altLang="en-US"/>
           </a:p>
@@ -1980,7 +1980,7 @@
           <a:p>
             <a:fld id="{4D43F9BF-FE5F-E647-B8EF-D6CA817AF965}" type="datetimeFigureOut">
               <a:rPr kumimoji="1" lang="zh-CN" altLang="en-US" smtClean="0"/>
-              <a:t>2026/5/25</a:t>
+              <a:t>2026/5/27</a:t>
             </a:fld>
             <a:endParaRPr kumimoji="1" lang="zh-CN" altLang="en-US"/>
           </a:p>
@@ -2245,7 +2245,7 @@
           <a:p>
             <a:fld id="{4D43F9BF-FE5F-E647-B8EF-D6CA817AF965}" type="datetimeFigureOut">
               <a:rPr kumimoji="1" lang="zh-CN" altLang="en-US" smtClean="0"/>
-              <a:t>2026/5/25</a:t>
+              <a:t>2026/5/27</a:t>
             </a:fld>
             <a:endParaRPr kumimoji="1" lang="zh-CN" altLang="en-US"/>
           </a:p>
@@ -2657,7 +2657,7 @@
           <a:p>
             <a:fld id="{4D43F9BF-FE5F-E647-B8EF-D6CA817AF965}" type="datetimeFigureOut">
               <a:rPr kumimoji="1" lang="zh-CN" altLang="en-US" smtClean="0"/>
-              <a:t>2026/5/25</a:t>
+              <a:t>2026/5/27</a:t>
             </a:fld>
             <a:endParaRPr kumimoji="1" lang="zh-CN" altLang="en-US"/>
           </a:p>
@@ -2798,7 +2798,7 @@
           <a:p>
             <a:fld id="{4D43F9BF-FE5F-E647-B8EF-D6CA817AF965}" type="datetimeFigureOut">
               <a:rPr kumimoji="1" lang="zh-CN" altLang="en-US" smtClean="0"/>
-              <a:t>2026/5/25</a:t>
+              <a:t>2026/5/27</a:t>
             </a:fld>
             <a:endParaRPr kumimoji="1" lang="zh-CN" altLang="en-US"/>
           </a:p>
@@ -2911,7 +2911,7 @@
           <a:p>
             <a:fld id="{4D43F9BF-FE5F-E647-B8EF-D6CA817AF965}" type="datetimeFigureOut">
               <a:rPr kumimoji="1" lang="zh-CN" altLang="en-US" smtClean="0"/>
-              <a:t>2026/5/25</a:t>
+              <a:t>2026/5/27</a:t>
             </a:fld>
             <a:endParaRPr kumimoji="1" lang="zh-CN" altLang="en-US"/>
           </a:p>
@@ -3222,7 +3222,7 @@
           <a:p>
             <a:fld id="{4D43F9BF-FE5F-E647-B8EF-D6CA817AF965}" type="datetimeFigureOut">
               <a:rPr kumimoji="1" lang="zh-CN" altLang="en-US" smtClean="0"/>
-              <a:t>2026/5/25</a:t>
+              <a:t>2026/5/27</a:t>
             </a:fld>
             <a:endParaRPr kumimoji="1" lang="zh-CN" altLang="en-US"/>
           </a:p>
@@ -3510,7 +3510,7 @@
           <a:p>
             <a:fld id="{4D43F9BF-FE5F-E647-B8EF-D6CA817AF965}" type="datetimeFigureOut">
               <a:rPr kumimoji="1" lang="zh-CN" altLang="en-US" smtClean="0"/>
-              <a:t>2026/5/25</a:t>
+              <a:t>2026/5/27</a:t>
             </a:fld>
             <a:endParaRPr kumimoji="1" lang="zh-CN" altLang="en-US"/>
           </a:p>
@@ -3751,7 +3751,7 @@
           <a:p>
             <a:fld id="{4D43F9BF-FE5F-E647-B8EF-D6CA817AF965}" type="datetimeFigureOut">
               <a:rPr kumimoji="1" lang="zh-CN" altLang="en-US" smtClean="0"/>
-              <a:t>2026/5/25</a:t>
+              <a:t>2026/5/27</a:t>
             </a:fld>
             <a:endParaRPr kumimoji="1" lang="zh-CN" altLang="en-US"/>
           </a:p>
@@ -4560,8 +4560,11 @@
           <a:p>
             <a:pPr marL="0" indent="0">
               <a:lnSpc>
-                <a:spcPct val="110000"/>
+                <a:spcPct val="120000"/>
               </a:lnSpc>
+              <a:spcAft>
+                <a:spcPts val="600"/>
+              </a:spcAft>
               <a:buNone/>
             </a:pPr>
             <a:r>
@@ -4580,17 +4583,11 @@
           <a:p>
             <a:pPr marL="0" indent="0">
               <a:lnSpc>
-                <a:spcPct val="110000"/>
+                <a:spcPct val="120000"/>
               </a:lnSpc>
-              <a:buNone/>
-            </a:pPr>
-            <a:endParaRPr lang="en-US" sz="1000" dirty="0"/>
-          </a:p>
-          <a:p>
-            <a:pPr marL="0" indent="0">
-              <a:lnSpc>
-                <a:spcPct val="110000"/>
-              </a:lnSpc>
+              <a:spcAft>
+                <a:spcPts val="600"/>
+              </a:spcAft>
               <a:buNone/>
             </a:pPr>
             <a:r>
@@ -4609,17 +4606,11 @@
           <a:p>
             <a:pPr marL="0" indent="0">
               <a:lnSpc>
-                <a:spcPct val="110000"/>
+                <a:spcPct val="120000"/>
               </a:lnSpc>
-              <a:buNone/>
-            </a:pPr>
-            <a:endParaRPr lang="en-US" sz="1000" dirty="0"/>
-          </a:p>
-          <a:p>
-            <a:pPr marL="0" indent="0">
-              <a:lnSpc>
-                <a:spcPct val="110000"/>
-              </a:lnSpc>
+              <a:spcAft>
+                <a:spcPts val="600"/>
+              </a:spcAft>
               <a:buNone/>
             </a:pPr>
             <a:r>
@@ -5608,8 +5599,11 @@
           <a:p>
             <a:pPr marL="0" indent="0">
               <a:lnSpc>
-                <a:spcPct val="110000"/>
+                <a:spcPct val="120000"/>
               </a:lnSpc>
+              <a:spcAft>
+                <a:spcPts val="600"/>
+              </a:spcAft>
               <a:buNone/>
             </a:pPr>
             <a:r>
@@ -5689,8 +5683,11 @@
           <a:p>
             <a:pPr marL="0" indent="0">
               <a:lnSpc>
-                <a:spcPct val="110000"/>
+                <a:spcPct val="120000"/>
               </a:lnSpc>
+              <a:spcAft>
+                <a:spcPts val="600"/>
+              </a:spcAft>
               <a:buNone/>
             </a:pPr>
             <a:r>
@@ -5770,8 +5767,11 @@
           <a:p>
             <a:pPr marL="0" indent="0">
               <a:lnSpc>
-                <a:spcPct val="110000"/>
+                <a:spcPct val="120000"/>
               </a:lnSpc>
+              <a:spcAft>
+                <a:spcPts val="600"/>
+              </a:spcAft>
               <a:buNone/>
             </a:pPr>
             <a:r>
@@ -5851,8 +5851,11 @@
           <a:p>
             <a:pPr marL="0" indent="0">
               <a:lnSpc>
-                <a:spcPct val="110000"/>
+                <a:spcPct val="120000"/>
               </a:lnSpc>
+              <a:spcAft>
+                <a:spcPts val="600"/>
+              </a:spcAft>
               <a:buNone/>
             </a:pPr>
             <a:r>
@@ -6442,8 +6445,11 @@
           <a:p>
             <a:pPr marL="0" indent="0">
               <a:lnSpc>
-                <a:spcPct val="110000"/>
+                <a:spcPct val="120000"/>
               </a:lnSpc>
+              <a:spcAft>
+                <a:spcPts val="600"/>
+              </a:spcAft>
               <a:buNone/>
             </a:pPr>
             <a:r>
@@ -6605,8 +6611,11 @@
           <a:p>
             <a:pPr marL="0" indent="0">
               <a:lnSpc>
-                <a:spcPct val="110000"/>
+                <a:spcPct val="120000"/>
               </a:lnSpc>
+              <a:spcAft>
+                <a:spcPts val="600"/>
+              </a:spcAft>
               <a:buNone/>
             </a:pPr>
             <a:r>
@@ -6764,8 +6773,11 @@
           <a:p>
             <a:pPr marL="0" indent="0">
               <a:lnSpc>
-                <a:spcPct val="110000"/>
+                <a:spcPct val="120000"/>
               </a:lnSpc>
+              <a:spcAft>
+                <a:spcPts val="600"/>
+              </a:spcAft>
               <a:buNone/>
             </a:pPr>
             <a:r>
@@ -6927,8 +6939,11 @@
           <a:p>
             <a:pPr marL="0" indent="0">
               <a:lnSpc>
-                <a:spcPct val="110000"/>
+                <a:spcPct val="120000"/>
               </a:lnSpc>
+              <a:spcAft>
+                <a:spcPts val="600"/>
+              </a:spcAft>
               <a:buNone/>
             </a:pPr>
             <a:r>
@@ -7735,8 +7750,11 @@
           <a:p>
             <a:pPr marL="0" indent="0">
               <a:lnSpc>
-                <a:spcPct val="110000"/>
+                <a:spcPct val="120000"/>
               </a:lnSpc>
+              <a:spcAft>
+                <a:spcPts val="600"/>
+              </a:spcAft>
               <a:buNone/>
             </a:pPr>
             <a:r>
@@ -7908,8 +7926,11 @@
           <a:p>
             <a:pPr marL="0" indent="0">
               <a:lnSpc>
-                <a:spcPct val="110000"/>
+                <a:spcPct val="120000"/>
               </a:lnSpc>
+              <a:spcAft>
+                <a:spcPts val="600"/>
+              </a:spcAft>
               <a:buNone/>
             </a:pPr>
             <a:r>
@@ -8081,8 +8102,11 @@
           <a:p>
             <a:pPr marL="0" indent="0">
               <a:lnSpc>
-                <a:spcPct val="110000"/>
+                <a:spcPct val="120000"/>
               </a:lnSpc>
+              <a:spcAft>
+                <a:spcPts val="600"/>
+              </a:spcAft>
               <a:buNone/>
             </a:pPr>
             <a:r>
@@ -8178,8 +8202,11 @@
           <a:p>
             <a:pPr>
               <a:lnSpc>
-                <a:spcPct val="110000"/>
+                <a:spcPct val="120000"/>
               </a:lnSpc>
+              <a:spcAft>
+                <a:spcPts val="600"/>
+              </a:spcAft>
             </a:pPr>
             <a:endParaRPr dirty="0"/>
           </a:p>
@@ -9000,7 +9027,7 @@
         <p:spPr>
           <a:xfrm>
             <a:off x="6035040" y="4038599"/>
-            <a:ext cx="4853984" cy="1069848"/>
+            <a:ext cx="5260848" cy="726552"/>
           </a:xfrm>
           <a:prstGeom prst="rect">
             <a:avLst/>
@@ -9014,8 +9041,11 @@
           <a:p>
             <a:pPr marL="0" indent="0">
               <a:lnSpc>
-                <a:spcPct val="110000"/>
+                <a:spcPct val="120000"/>
               </a:lnSpc>
+              <a:spcAft>
+                <a:spcPts val="600"/>
+              </a:spcAft>
               <a:buNone/>
             </a:pPr>
             <a:r>
@@ -9173,7 +9203,7 @@
         <p:spPr>
           <a:xfrm>
             <a:off x="6035040" y="5201876"/>
-            <a:ext cx="4853984" cy="1069848"/>
+            <a:ext cx="5260848" cy="724262"/>
           </a:xfrm>
           <a:prstGeom prst="rect">
             <a:avLst/>
@@ -9187,8 +9217,11 @@
           <a:p>
             <a:pPr marL="0" indent="0">
               <a:lnSpc>
-                <a:spcPct val="110000"/>
+                <a:spcPct val="120000"/>
               </a:lnSpc>
+              <a:spcAft>
+                <a:spcPts val="600"/>
+              </a:spcAft>
               <a:buNone/>
             </a:pPr>
             <a:r>
@@ -10275,8 +10308,11 @@
           <a:p>
             <a:pPr marL="0" indent="0">
               <a:lnSpc>
-                <a:spcPct val="110000"/>
+                <a:spcPct val="120000"/>
               </a:lnSpc>
+              <a:spcAft>
+                <a:spcPts val="600"/>
+              </a:spcAft>
               <a:buNone/>
             </a:pPr>
             <a:r>
@@ -10434,8 +10470,11 @@
           <a:p>
             <a:pPr marL="0" indent="0">
               <a:lnSpc>
-                <a:spcPct val="110000"/>
+                <a:spcPct val="120000"/>
               </a:lnSpc>
+              <a:spcAft>
+                <a:spcPts val="600"/>
+              </a:spcAft>
               <a:buNone/>
             </a:pPr>
             <a:r>
@@ -10593,8 +10632,11 @@
           <a:p>
             <a:pPr marL="0" indent="0">
               <a:lnSpc>
-                <a:spcPct val="110000"/>
+                <a:spcPct val="120000"/>
               </a:lnSpc>
+              <a:spcAft>
+                <a:spcPts val="600"/>
+              </a:spcAft>
               <a:buNone/>
             </a:pPr>
             <a:r>
@@ -10752,8 +10794,11 @@
           <a:p>
             <a:pPr marL="0" indent="0">
               <a:lnSpc>
-                <a:spcPct val="110000"/>
+                <a:spcPct val="120000"/>
               </a:lnSpc>
+              <a:spcAft>
+                <a:spcPts val="600"/>
+              </a:spcAft>
               <a:buNone/>
             </a:pPr>
             <a:r>
@@ -11376,8 +11421,11 @@
           <a:p>
             <a:pPr marL="0" indent="0">
               <a:lnSpc>
-                <a:spcPct val="110000"/>
+                <a:spcPct val="120000"/>
               </a:lnSpc>
+              <a:spcAft>
+                <a:spcPts val="600"/>
+              </a:spcAft>
               <a:buNone/>
             </a:pPr>
             <a:r>
@@ -11535,8 +11583,11 @@
           <a:p>
             <a:pPr marL="0" indent="0">
               <a:lnSpc>
-                <a:spcPct val="110000"/>
+                <a:spcPct val="120000"/>
               </a:lnSpc>
+              <a:spcAft>
+                <a:spcPts val="600"/>
+              </a:spcAft>
               <a:buNone/>
             </a:pPr>
             <a:r>
@@ -11694,8 +11745,11 @@
           <a:p>
             <a:pPr marL="0" indent="0">
               <a:lnSpc>
-                <a:spcPct val="110000"/>
+                <a:spcPct val="120000"/>
               </a:lnSpc>
+              <a:spcAft>
+                <a:spcPts val="600"/>
+              </a:spcAft>
               <a:buNone/>
             </a:pPr>
             <a:r>
@@ -11853,8 +11907,11 @@
           <a:p>
             <a:pPr marL="0" indent="0">
               <a:lnSpc>
-                <a:spcPct val="110000"/>
+                <a:spcPct val="120000"/>
               </a:lnSpc>
+              <a:spcAft>
+                <a:spcPts val="600"/>
+              </a:spcAft>
               <a:buNone/>
             </a:pPr>
             <a:r>
@@ -12012,8 +12069,11 @@
           <a:p>
             <a:pPr marL="0" indent="0">
               <a:lnSpc>
-                <a:spcPct val="110000"/>
+                <a:spcPct val="120000"/>
               </a:lnSpc>
+              <a:spcAft>
+                <a:spcPts val="600"/>
+              </a:spcAft>
               <a:buNone/>
             </a:pPr>
             <a:r>
@@ -12175,8 +12235,11 @@
           <a:p>
             <a:pPr marL="0" indent="0">
               <a:lnSpc>
-                <a:spcPct val="110000"/>
+                <a:spcPct val="120000"/>
               </a:lnSpc>
+              <a:spcAft>
+                <a:spcPts val="600"/>
+              </a:spcAft>
               <a:buNone/>
             </a:pPr>
             <a:r>
@@ -12799,8 +12862,11 @@
           <a:p>
             <a:pPr marL="0" indent="0">
               <a:lnSpc>
-                <a:spcPct val="110000"/>
+                <a:spcPct val="120000"/>
               </a:lnSpc>
+              <a:spcAft>
+                <a:spcPts val="600"/>
+              </a:spcAft>
               <a:buNone/>
             </a:pPr>
             <a:r>
@@ -12958,8 +13024,11 @@
           <a:p>
             <a:pPr marL="0" indent="0">
               <a:lnSpc>
-                <a:spcPct val="110000"/>
+                <a:spcPct val="120000"/>
               </a:lnSpc>
+              <a:spcAft>
+                <a:spcPts val="600"/>
+              </a:spcAft>
               <a:buNone/>
             </a:pPr>
             <a:r>
@@ -13117,8 +13186,11 @@
           <a:p>
             <a:pPr marL="0" indent="0">
               <a:lnSpc>
-                <a:spcPct val="110000"/>
+                <a:spcPct val="120000"/>
               </a:lnSpc>
+              <a:spcAft>
+                <a:spcPts val="600"/>
+              </a:spcAft>
               <a:buNone/>
             </a:pPr>
             <a:r>
@@ -13861,8 +13933,11 @@
           <a:p>
             <a:pPr marL="0" indent="0">
               <a:lnSpc>
-                <a:spcPct val="110000"/>
+                <a:spcPct val="120000"/>
               </a:lnSpc>
+              <a:spcAft>
+                <a:spcPts val="600"/>
+              </a:spcAft>
               <a:buNone/>
             </a:pPr>
             <a:r>
@@ -14020,8 +14095,11 @@
           <a:p>
             <a:pPr marL="0" indent="0">
               <a:lnSpc>
-                <a:spcPct val="110000"/>
+                <a:spcPct val="120000"/>
               </a:lnSpc>
+              <a:spcAft>
+                <a:spcPts val="600"/>
+              </a:spcAft>
               <a:buNone/>
             </a:pPr>
             <a:r>
@@ -14183,8 +14261,11 @@
           <a:p>
             <a:pPr marL="0" indent="0">
               <a:lnSpc>
-                <a:spcPct val="110000"/>
+                <a:spcPct val="120000"/>
               </a:lnSpc>
+              <a:spcAft>
+                <a:spcPts val="600"/>
+              </a:spcAft>
               <a:buNone/>
             </a:pPr>
             <a:r>
@@ -15732,8 +15813,11 @@
           <a:p>
             <a:pPr marL="0" indent="0">
               <a:lnSpc>
-                <a:spcPct val="110000"/>
+                <a:spcPct val="120000"/>
               </a:lnSpc>
+              <a:spcAft>
+                <a:spcPts val="600"/>
+              </a:spcAft>
               <a:buNone/>
             </a:pPr>
             <a:r>
@@ -15891,8 +15975,11 @@
           <a:p>
             <a:pPr marL="0" indent="0">
               <a:lnSpc>
-                <a:spcPct val="110000"/>
+                <a:spcPct val="120000"/>
               </a:lnSpc>
+              <a:spcAft>
+                <a:spcPts val="600"/>
+              </a:spcAft>
               <a:buNone/>
             </a:pPr>
             <a:r>
@@ -16054,8 +16141,11 @@
           <a:p>
             <a:pPr marL="0" indent="0">
               <a:lnSpc>
-                <a:spcPct val="110000"/>
+                <a:spcPct val="120000"/>
               </a:lnSpc>
+              <a:spcAft>
+                <a:spcPts val="600"/>
+              </a:spcAft>
               <a:buNone/>
             </a:pPr>
             <a:r>
@@ -16936,8 +17026,11 @@
           <a:p>
             <a:pPr marL="0" indent="0">
               <a:lnSpc>
-                <a:spcPct val="110000"/>
+                <a:spcPct val="120000"/>
               </a:lnSpc>
+              <a:spcAft>
+                <a:spcPts val="600"/>
+              </a:spcAft>
               <a:buNone/>
             </a:pPr>
             <a:r>
@@ -17091,8 +17184,11 @@
           <a:p>
             <a:pPr marL="0" indent="0">
               <a:lnSpc>
-                <a:spcPct val="110000"/>
+                <a:spcPct val="120000"/>
               </a:lnSpc>
+              <a:spcAft>
+                <a:spcPts val="600"/>
+              </a:spcAft>
               <a:buNone/>
             </a:pPr>
             <a:r>
@@ -17247,8 +17343,11 @@
           <a:p>
             <a:pPr marL="0" indent="0">
               <a:lnSpc>
-                <a:spcPct val="110000"/>
+                <a:spcPct val="120000"/>
               </a:lnSpc>
+              <a:spcAft>
+                <a:spcPts val="600"/>
+              </a:spcAft>
               <a:buNone/>
             </a:pPr>
             <a:r>

</xml_diff>